<commit_message>
docs: 9-slide Agent Console deck, 23.10 submission delta, judge checklist audit
</commit_message>
<xml_diff>
--- a/docs/deck.pptx
+++ b/docs/deck.pptx
@@ -13,6 +13,7 @@
     <p:sldId id="261" r:id="rId12"/>
     <p:sldId id="262" r:id="rId13"/>
     <p:sldId id="263" r:id="rId14"/>
+    <p:sldId id="264" r:id="rId15"/>
   </p:sldIdLst>
   <p:sldSz cx="12191695" cy="6858000" type="screen4x3"/>
   <p:notesSz cx="6858000" cy="9144000"/>
@@ -3547,7 +3548,7 @@
                 </a:solidFill>
                 <a:latin typeface="Segoe UI"/>
               </a:rPr>
-              <a:t>Sourcify exact_match · 69 tests · no owner, no fee</a:t>
+              <a:t>Sourcify exact_match · 79 tests · no owner, no fee</a:t>
             </a:r>
           </a:p>
         </p:txBody>
@@ -3625,7 +3626,7 @@
                 </a:solidFill>
                 <a:latin typeface="Segoe UI"/>
               </a:rPr>
-              <a:t>1/8</a:t>
+              <a:t>1/9</a:t>
             </a:r>
           </a:p>
         </p:txBody>
@@ -4200,7 +4201,7 @@
                 </a:solidFill>
                 <a:latin typeface="Segoe UI"/>
               </a:rPr>
-              <a:t>2/8</a:t>
+              <a:t>2/9</a:t>
             </a:r>
           </a:p>
         </p:txBody>
@@ -5164,7 +5165,7 @@
                 </a:solidFill>
                 <a:latin typeface="Segoe UI"/>
               </a:rPr>
-              <a:t>3/8</a:t>
+              <a:t>3/9</a:t>
             </a:r>
           </a:p>
         </p:txBody>
@@ -5739,7 +5740,7 @@
                 </a:solidFill>
                 <a:latin typeface="Segoe UI"/>
               </a:rPr>
-              <a:t>4/8</a:t>
+              <a:t>4/9</a:t>
             </a:r>
           </a:p>
         </p:txBody>
@@ -6256,7 +6257,7 @@
                 </a:solidFill>
                 <a:latin typeface="Segoe UI"/>
               </a:rPr>
-              <a:t>5/8</a:t>
+              <a:t>5/9</a:t>
             </a:r>
           </a:p>
         </p:txBody>
@@ -6490,7 +6491,7 @@
                 </a:solidFill>
                 <a:latin typeface="Segoe UI"/>
               </a:rPr>
-              <a:t>69 tests</a:t>
+              <a:t>79 tests</a:t>
             </a:r>
           </a:p>
         </p:txBody>
@@ -7200,7 +7201,7 @@
                 </a:solidFill>
                 <a:latin typeface="Segoe UI"/>
               </a:rPr>
-              <a:t>npm test        # 69 passing</a:t>
+              <a:t>npm test        # 79 passing</a:t>
             </a:r>
           </a:p>
           <a:p>
@@ -7445,7 +7446,7 @@
                 </a:solidFill>
                 <a:latin typeface="Segoe UI"/>
               </a:rPr>
-              <a:t>6/8</a:t>
+              <a:t>6/9</a:t>
             </a:r>
           </a:p>
         </p:txBody>
@@ -8183,7 +8184,7 @@
                 </a:solidFill>
                 <a:latin typeface="Segoe UI"/>
               </a:rPr>
-              <a:t>7/8</a:t>
+              <a:t>7/9</a:t>
             </a:r>
           </a:p>
         </p:txBody>
@@ -9056,7 +9057,710 @@
                 </a:solidFill>
                 <a:latin typeface="Segoe UI"/>
               </a:rPr>
-              <a:t>8/8</a:t>
+              <a:t>8/9</a:t>
+            </a:r>
+          </a:p>
+        </p:txBody>
+      </p:sp>
+    </p:spTree>
+  </p:cSld>
+  <p:clrMapOvr>
+    <a:masterClrMapping/>
+  </p:clrMapOvr>
+</p:sld>
+</file>
+
+<file path=ppt/slides/slide9.xml><?xml version="1.0" encoding="utf-8"?>
+<p:sld xmlns:a="http://schemas.openxmlformats.org/drawingml/2006/main" xmlns:p="http://schemas.openxmlformats.org/presentationml/2006/main" xmlns:r="http://schemas.openxmlformats.org/officeDocument/2006/relationships">
+  <p:cSld>
+    <p:bg>
+      <p:bgPr>
+        <a:solidFill>
+          <a:srgbClr val="04130C"/>
+        </a:solidFill>
+        <a:effectLst/>
+      </p:bgPr>
+    </p:bg>
+    <p:spTree>
+      <p:nvGrpSpPr>
+        <p:cNvPr id="1" name=""/>
+        <p:cNvGrpSpPr/>
+        <p:nvPr/>
+      </p:nvGrpSpPr>
+      <p:grpSpPr/>
+      <p:sp>
+        <p:nvSpPr>
+          <p:cNvPr id="2" name="TextBox 1"/>
+          <p:cNvSpPr txBox="1"/>
+          <p:nvPr/>
+        </p:nvSpPr>
+        <p:spPr>
+          <a:xfrm>
+            <a:off x="640080" y="411480"/>
+            <a:ext cx="10972800" cy="365760"/>
+          </a:xfrm>
+          <a:prstGeom prst="rect">
+            <a:avLst/>
+          </a:prstGeom>
+          <a:noFill/>
+        </p:spPr>
+        <p:txBody>
+          <a:bodyPr wrap="square" anchor="t" lIns="0" rIns="0" tIns="0" bIns="0">
+            <a:spAutoFit/>
+          </a:bodyPr>
+          <a:lstStyle/>
+          <a:p>
+            <a:pPr algn="l">
+              <a:spcAft>
+                <a:spcPts val="600"/>
+              </a:spcAft>
+            </a:pPr>
+            <a:r>
+              <a:rPr sz="1200" b="1">
+                <a:solidFill>
+                  <a:srgbClr val="00D68F"/>
+                </a:solidFill>
+                <a:latin typeface="Segoe UI"/>
+              </a:rPr>
+              <a:t>NEW · 23 OCT 2026</a:t>
+            </a:r>
+          </a:p>
+        </p:txBody>
+      </p:sp>
+      <p:sp>
+        <p:nvSpPr>
+          <p:cNvPr id="3" name="TextBox 2"/>
+          <p:cNvSpPr txBox="1"/>
+          <p:nvPr/>
+        </p:nvSpPr>
+        <p:spPr>
+          <a:xfrm>
+            <a:off x="640080" y="777240"/>
+            <a:ext cx="10972800" cy="914400"/>
+          </a:xfrm>
+          <a:prstGeom prst="rect">
+            <a:avLst/>
+          </a:prstGeom>
+          <a:noFill/>
+        </p:spPr>
+        <p:txBody>
+          <a:bodyPr wrap="square" anchor="t" lIns="0" rIns="0" tIns="0" bIns="0">
+            <a:spAutoFit/>
+          </a:bodyPr>
+          <a:lstStyle/>
+          <a:p>
+            <a:pPr algn="l">
+              <a:spcAft>
+                <a:spcPts val="600"/>
+              </a:spcAft>
+            </a:pPr>
+            <a:r>
+              <a:rPr sz="3400" b="1">
+                <a:solidFill>
+                  <a:srgbClr val="E8F5EE"/>
+                </a:solidFill>
+                <a:latin typeface="Segoe UI"/>
+              </a:rPr>
+              <a:t>The same escrow, operable by an agent</a:t>
+            </a:r>
+          </a:p>
+        </p:txBody>
+      </p:sp>
+      <p:sp>
+        <p:nvSpPr>
+          <p:cNvPr id="4" name="Rectangle 3"/>
+          <p:cNvSpPr/>
+          <p:nvPr/>
+        </p:nvSpPr>
+        <p:spPr>
+          <a:xfrm>
+            <a:off x="640080" y="1691640"/>
+            <a:ext cx="1463040" cy="38100"/>
+          </a:xfrm>
+          <a:prstGeom prst="rect">
+            <a:avLst/>
+          </a:prstGeom>
+          <a:solidFill>
+            <a:srgbClr val="00D68F"/>
+          </a:solidFill>
+          <a:ln>
+            <a:noFill/>
+          </a:ln>
+        </p:spPr>
+        <p:style>
+          <a:lnRef idx="1">
+            <a:schemeClr val="accent1"/>
+          </a:lnRef>
+          <a:fillRef idx="3">
+            <a:schemeClr val="accent1"/>
+          </a:fillRef>
+          <a:effectRef idx="2">
+            <a:schemeClr val="accent1"/>
+          </a:effectRef>
+          <a:fontRef idx="minor">
+            <a:schemeClr val="lt1"/>
+          </a:fontRef>
+        </p:style>
+        <p:txBody>
+          <a:bodyPr rtlCol="0" anchor="ctr"/>
+          <a:lstStyle/>
+          <a:p>
+            <a:pPr algn="ctr"/>
+          </a:p>
+        </p:txBody>
+      </p:sp>
+      <p:sp>
+        <p:nvSpPr>
+          <p:cNvPr id="5" name="Rounded Rectangle 4"/>
+          <p:cNvSpPr/>
+          <p:nvPr/>
+        </p:nvSpPr>
+        <p:spPr>
+          <a:xfrm>
+            <a:off x="640080" y="1965960"/>
+            <a:ext cx="5394960" cy="3840480"/>
+          </a:xfrm>
+          <a:prstGeom prst="roundRect">
+            <a:avLst>
+              <a:gd name="adj" fmla="val 6000"/>
+            </a:avLst>
+          </a:prstGeom>
+          <a:solidFill>
+            <a:srgbClr val="0A2015"/>
+          </a:solidFill>
+          <a:ln w="12700">
+            <a:solidFill>
+              <a:srgbClr val="1D4A33"/>
+            </a:solidFill>
+          </a:ln>
+          <a:effectLst/>
+        </p:spPr>
+        <p:style>
+          <a:lnRef idx="1">
+            <a:schemeClr val="accent1"/>
+          </a:lnRef>
+          <a:fillRef idx="3">
+            <a:schemeClr val="accent1"/>
+          </a:fillRef>
+          <a:effectRef idx="2">
+            <a:schemeClr val="accent1"/>
+          </a:effectRef>
+          <a:fontRef idx="minor">
+            <a:schemeClr val="lt1"/>
+          </a:fontRef>
+        </p:style>
+        <p:txBody>
+          <a:bodyPr rtlCol="0" anchor="ctr"/>
+          <a:lstStyle/>
+          <a:p>
+            <a:pPr algn="ctr"/>
+          </a:p>
+        </p:txBody>
+      </p:sp>
+      <p:sp>
+        <p:nvSpPr>
+          <p:cNvPr id="6" name="TextBox 5"/>
+          <p:cNvSpPr txBox="1"/>
+          <p:nvPr/>
+        </p:nvSpPr>
+        <p:spPr>
+          <a:xfrm>
+            <a:off x="868680" y="2148840"/>
+            <a:ext cx="4937760" cy="3474720"/>
+          </a:xfrm>
+          <a:prstGeom prst="rect">
+            <a:avLst/>
+          </a:prstGeom>
+          <a:noFill/>
+        </p:spPr>
+        <p:txBody>
+          <a:bodyPr wrap="square" anchor="t" lIns="0" rIns="0" tIns="0" bIns="0">
+            <a:spAutoFit/>
+          </a:bodyPr>
+          <a:lstStyle/>
+          <a:p>
+            <a:pPr algn="l">
+              <a:spcAft>
+                <a:spcPts val="600"/>
+              </a:spcAft>
+            </a:pPr>
+            <a:r>
+              <a:rPr sz="1600" b="1">
+                <a:solidFill>
+                  <a:srgbClr val="00D68F"/>
+                </a:solidFill>
+                <a:latin typeface="Segoe UI"/>
+              </a:rPr>
+              <a:t>Machine-readable CLI</a:t>
+            </a:r>
+          </a:p>
+          <a:p>
+            <a:pPr algn="l">
+              <a:spcAft>
+                <a:spcPts val="600"/>
+              </a:spcAft>
+            </a:pPr>
+            <a:r>
+              <a:rPr sz="1100" b="0">
+                <a:solidFill>
+                  <a:srgbClr val="8FB5A1"/>
+                </a:solidFill>
+                <a:latin typeface="Segoe UI"/>
+              </a:rPr>
+              <a:t>scripts/agent-console.js — no UI, no keys printed</a:t>
+            </a:r>
+          </a:p>
+          <a:p>
+            <a:pPr algn="l">
+              <a:spcAft>
+                <a:spcPts val="600"/>
+              </a:spcAft>
+            </a:pPr>
+            <a:r>
+              <a:rPr sz="500" b="0">
+                <a:solidFill>
+                  <a:srgbClr val="E8F5EE"/>
+                </a:solidFill>
+                <a:latin typeface="Segoe UI"/>
+              </a:rPr>
+              <a:t/>
+            </a:r>
+          </a:p>
+          <a:p>
+            <a:pPr algn="l" indent="-171450" marL="171450">
+              <a:spcAft>
+                <a:spcPts val="600"/>
+              </a:spcAft>
+            </a:pPr>
+            <a:r>
+              <a:rPr sz="1200" b="0">
+                <a:solidFill>
+                  <a:srgbClr val="E8F5EE"/>
+                </a:solidFill>
+                <a:latin typeface="Segoe UI"/>
+              </a:rPr>
+              <a:t>•  status · jobs list · job get · watch · verify</a:t>
+            </a:r>
+          </a:p>
+          <a:p>
+            <a:pPr algn="l" indent="-171450" marL="171450">
+              <a:spcAft>
+                <a:spcPts val="600"/>
+              </a:spcAft>
+            </a:pPr>
+            <a:r>
+              <a:rPr sz="1200" b="0">
+                <a:solidFill>
+                  <a:srgbClr val="E8F5EE"/>
+                </a:solidFill>
+                <a:latin typeface="Segoe UI"/>
+              </a:rPr>
+              <a:t>•  lifecycle commands build calldata; --dry-run is the default</a:t>
+            </a:r>
+          </a:p>
+          <a:p>
+            <a:pPr algn="l" indent="-171450" marL="171450">
+              <a:spcAft>
+                <a:spcPts val="600"/>
+              </a:spcAft>
+            </a:pPr>
+            <a:r>
+              <a:rPr sz="1200" b="0">
+                <a:solidFill>
+                  <a:srgbClr val="E8F5EE"/>
+                </a:solidFill>
+                <a:latin typeface="Segoe UI"/>
+              </a:rPr>
+              <a:t>•  exit codes 0/1/2/3 = ok / input / network / revert</a:t>
+            </a:r>
+          </a:p>
+          <a:p>
+            <a:pPr algn="l" indent="-171450" marL="171450">
+              <a:spcAft>
+                <a:spcPts val="600"/>
+              </a:spcAft>
+            </a:pPr>
+            <a:r>
+              <a:rPr sz="1200" b="0">
+                <a:solidFill>
+                  <a:srgbClr val="E8F5EE"/>
+                </a:solidFill>
+                <a:latin typeface="Segoe UI"/>
+              </a:rPr>
+              <a:t>•  10 new tests; npm test = 79 passing</a:t>
+            </a:r>
+          </a:p>
+          <a:p>
+            <a:pPr algn="l" indent="-171450" marL="171450">
+              <a:spcAft>
+                <a:spcPts val="600"/>
+              </a:spcAft>
+            </a:pPr>
+            <a:r>
+              <a:rPr sz="1200" b="0">
+                <a:solidFill>
+                  <a:srgbClr val="E8F5EE"/>
+                </a:solidFill>
+                <a:latin typeface="Segoe UI"/>
+              </a:rPr>
+              <a:t>•  commit fbf6fb8; contract unchanged</a:t>
+            </a:r>
+          </a:p>
+          <a:p>
+            <a:pPr algn="l">
+              <a:spcAft>
+                <a:spcPts val="600"/>
+              </a:spcAft>
+            </a:pPr>
+            <a:r>
+              <a:rPr sz="500" b="0">
+                <a:solidFill>
+                  <a:srgbClr val="E8F5EE"/>
+                </a:solidFill>
+                <a:latin typeface="Segoe UI"/>
+              </a:rPr>
+              <a:t/>
+            </a:r>
+          </a:p>
+          <a:p>
+            <a:pPr algn="l">
+              <a:spcAft>
+                <a:spcPts val="600"/>
+              </a:spcAft>
+            </a:pPr>
+            <a:r>
+              <a:rPr sz="1000" b="0">
+                <a:solidFill>
+                  <a:srgbClr val="8FB5A1"/>
+                </a:solidFill>
+                <a:latin typeface="Segoe UI"/>
+              </a:rPr>
+              <a:t>Read-only calls checked against the deployed contract; no transaction sent.</a:t>
+            </a:r>
+          </a:p>
+        </p:txBody>
+      </p:sp>
+      <p:sp>
+        <p:nvSpPr>
+          <p:cNvPr id="7" name="Rounded Rectangle 6"/>
+          <p:cNvSpPr/>
+          <p:nvPr/>
+        </p:nvSpPr>
+        <p:spPr>
+          <a:xfrm>
+            <a:off x="6309360" y="1965960"/>
+            <a:ext cx="5212080" cy="3840480"/>
+          </a:xfrm>
+          <a:prstGeom prst="roundRect">
+            <a:avLst>
+              <a:gd name="adj" fmla="val 6000"/>
+            </a:avLst>
+          </a:prstGeom>
+          <a:solidFill>
+            <a:srgbClr val="06180F"/>
+          </a:solidFill>
+          <a:ln w="12700">
+            <a:solidFill>
+              <a:srgbClr val="1D4A33"/>
+            </a:solidFill>
+          </a:ln>
+          <a:effectLst/>
+        </p:spPr>
+        <p:style>
+          <a:lnRef idx="1">
+            <a:schemeClr val="accent1"/>
+          </a:lnRef>
+          <a:fillRef idx="3">
+            <a:schemeClr val="accent1"/>
+          </a:fillRef>
+          <a:effectRef idx="2">
+            <a:schemeClr val="accent1"/>
+          </a:effectRef>
+          <a:fontRef idx="minor">
+            <a:schemeClr val="lt1"/>
+          </a:fontRef>
+        </p:style>
+        <p:txBody>
+          <a:bodyPr rtlCol="0" anchor="ctr"/>
+          <a:lstStyle/>
+          <a:p>
+            <a:pPr algn="ctr"/>
+          </a:p>
+        </p:txBody>
+      </p:sp>
+      <p:sp>
+        <p:nvSpPr>
+          <p:cNvPr id="8" name="TextBox 7"/>
+          <p:cNvSpPr txBox="1"/>
+          <p:nvPr/>
+        </p:nvSpPr>
+        <p:spPr>
+          <a:xfrm>
+            <a:off x="6492240" y="2103120"/>
+            <a:ext cx="4846320" cy="3474720"/>
+          </a:xfrm>
+          <a:prstGeom prst="rect">
+            <a:avLst/>
+          </a:prstGeom>
+          <a:noFill/>
+        </p:spPr>
+        <p:txBody>
+          <a:bodyPr wrap="square" anchor="t" lIns="0" rIns="0" tIns="0" bIns="0">
+            <a:spAutoFit/>
+          </a:bodyPr>
+          <a:lstStyle/>
+          <a:p>
+            <a:pPr algn="l">
+              <a:spcAft>
+                <a:spcPts val="300"/>
+              </a:spcAft>
+            </a:pPr>
+            <a:r>
+              <a:rPr sz="1000" b="1">
+                <a:solidFill>
+                  <a:srgbClr val="00D68F"/>
+                </a:solidFill>
+                <a:latin typeface="Segoe UI"/>
+              </a:rPr>
+              <a:t>$ npm run agent -- verify --json</a:t>
+            </a:r>
+          </a:p>
+          <a:p>
+            <a:pPr algn="l">
+              <a:spcAft>
+                <a:spcPts val="300"/>
+              </a:spcAft>
+            </a:pPr>
+            <a:r>
+              <a:rPr sz="1000" b="0">
+                <a:solidFill>
+                  <a:srgbClr val="E8F5EE"/>
+                </a:solidFill>
+                <a:latin typeface="Segoe UI"/>
+              </a:rPr>
+              <a:t>{</a:t>
+            </a:r>
+          </a:p>
+          <a:p>
+            <a:pPr algn="l">
+              <a:spcAft>
+                <a:spcPts val="300"/>
+              </a:spcAft>
+            </a:pPr>
+            <a:r>
+              <a:rPr sz="1000" b="0">
+                <a:solidFill>
+                  <a:srgbClr val="E8F5EE"/>
+                </a:solidFill>
+                <a:latin typeface="Segoe UI"/>
+              </a:rPr>
+              <a:t>  "chainId": 31611,</a:t>
+            </a:r>
+          </a:p>
+          <a:p>
+            <a:pPr algn="l">
+              <a:spcAft>
+                <a:spcPts val="300"/>
+              </a:spcAft>
+            </a:pPr>
+            <a:r>
+              <a:rPr sz="900" b="0">
+                <a:solidFill>
+                  <a:srgbClr val="E8F5EE"/>
+                </a:solidFill>
+                <a:latin typeface="Segoe UI"/>
+              </a:rPr>
+              <a:t>  "escrow": "0x247b313d0eD3C532B16c7E5f9eA760272361600F",</a:t>
+            </a:r>
+          </a:p>
+          <a:p>
+            <a:pPr algn="l">
+              <a:spcAft>
+                <a:spcPts val="300"/>
+              </a:spcAft>
+            </a:pPr>
+            <a:r>
+              <a:rPr sz="900" b="0">
+                <a:solidFill>
+                  <a:srgbClr val="E8F5EE"/>
+                </a:solidFill>
+                <a:latin typeface="Segoe UI"/>
+              </a:rPr>
+              <a:t>  "musd": "0x118917a40FAF1CD7a13dB0Ef56C86De7973Ac503",</a:t>
+            </a:r>
+          </a:p>
+          <a:p>
+            <a:pPr algn="l">
+              <a:spcAft>
+                <a:spcPts val="300"/>
+              </a:spcAft>
+            </a:pPr>
+            <a:r>
+              <a:rPr sz="1000" b="0">
+                <a:solidFill>
+                  <a:srgbClr val="E8F5EE"/>
+                </a:solidFill>
+                <a:latin typeface="Segoe UI"/>
+              </a:rPr>
+              <a:t>  "musdMatches": true,</a:t>
+            </a:r>
+          </a:p>
+          <a:p>
+            <a:pPr algn="l">
+              <a:spcAft>
+                <a:spcPts val="300"/>
+              </a:spcAft>
+            </a:pPr>
+            <a:r>
+              <a:rPr sz="1000" b="0">
+                <a:solidFill>
+                  <a:srgbClr val="E8F5EE"/>
+                </a:solidFill>
+                <a:latin typeface="Segoe UI"/>
+              </a:rPr>
+              <a:t>  "reviewPeriodSeconds": 148,</a:t>
+            </a:r>
+          </a:p>
+          <a:p>
+            <a:pPr algn="l">
+              <a:spcAft>
+                <a:spcPts val="300"/>
+              </a:spcAft>
+            </a:pPr>
+            <a:r>
+              <a:rPr sz="1000" b="0">
+                <a:solidFill>
+                  <a:srgbClr val="E8F5EE"/>
+                </a:solidFill>
+                <a:latin typeface="Segoe UI"/>
+              </a:rPr>
+              <a:t>  "ok": true</a:t>
+            </a:r>
+          </a:p>
+          <a:p>
+            <a:pPr algn="l">
+              <a:spcAft>
+                <a:spcPts val="300"/>
+              </a:spcAft>
+            </a:pPr>
+            <a:r>
+              <a:rPr sz="1000" b="0">
+                <a:solidFill>
+                  <a:srgbClr val="E8F5EE"/>
+                </a:solidFill>
+                <a:latin typeface="Segoe UI"/>
+              </a:rPr>
+              <a:t>}</a:t>
+            </a:r>
+          </a:p>
+          <a:p>
+            <a:pPr algn="l">
+              <a:spcAft>
+                <a:spcPts val="300"/>
+              </a:spcAft>
+            </a:pPr>
+            <a:r>
+              <a:rPr sz="1000" b="1">
+                <a:solidFill>
+                  <a:srgbClr val="00D68F"/>
+                </a:solidFill>
+                <a:latin typeface="Segoe UI"/>
+              </a:rPr>
+              <a:t>$ npm test</a:t>
+            </a:r>
+          </a:p>
+          <a:p>
+            <a:pPr algn="l">
+              <a:spcAft>
+                <a:spcPts val="300"/>
+              </a:spcAft>
+            </a:pPr>
+            <a:r>
+              <a:rPr sz="1100" b="1">
+                <a:solidFill>
+                  <a:srgbClr val="00D68F"/>
+                </a:solidFill>
+                <a:latin typeface="Segoe UI"/>
+              </a:rPr>
+              <a:t>79 passing</a:t>
+            </a:r>
+          </a:p>
+        </p:txBody>
+      </p:sp>
+      <p:sp>
+        <p:nvSpPr>
+          <p:cNvPr id="9" name="TextBox 8"/>
+          <p:cNvSpPr txBox="1"/>
+          <p:nvPr/>
+        </p:nvSpPr>
+        <p:spPr>
+          <a:xfrm>
+            <a:off x="640080" y="6400800"/>
+            <a:ext cx="8229600" cy="274320"/>
+          </a:xfrm>
+          <a:prstGeom prst="rect">
+            <a:avLst/>
+          </a:prstGeom>
+          <a:noFill/>
+        </p:spPr>
+        <p:txBody>
+          <a:bodyPr wrap="square" anchor="t" lIns="0" rIns="0" tIns="0" bIns="0">
+            <a:spAutoFit/>
+          </a:bodyPr>
+          <a:lstStyle/>
+          <a:p>
+            <a:pPr algn="l">
+              <a:spcAft>
+                <a:spcPts val="600"/>
+              </a:spcAft>
+            </a:pPr>
+            <a:r>
+              <a:rPr sz="1000" b="0">
+                <a:solidFill>
+                  <a:srgbClr val="8FB5A1"/>
+                </a:solidFill>
+                <a:latin typeface="Segoe UI"/>
+              </a:rPr>
+              <a:t>MezoGig · milestone escrow in MUSD on Mezo · AKINDO “Build with MUSD and MEZO”, Wave 1</a:t>
+            </a:r>
+          </a:p>
+        </p:txBody>
+      </p:sp>
+      <p:sp>
+        <p:nvSpPr>
+          <p:cNvPr id="10" name="TextBox 9"/>
+          <p:cNvSpPr txBox="1"/>
+          <p:nvPr/>
+        </p:nvSpPr>
+        <p:spPr>
+          <a:xfrm>
+            <a:off x="10789920" y="6400800"/>
+            <a:ext cx="822960" cy="274320"/>
+          </a:xfrm>
+          <a:prstGeom prst="rect">
+            <a:avLst/>
+          </a:prstGeom>
+          <a:noFill/>
+        </p:spPr>
+        <p:txBody>
+          <a:bodyPr wrap="square" anchor="t" lIns="0" rIns="0" tIns="0" bIns="0">
+            <a:spAutoFit/>
+          </a:bodyPr>
+          <a:lstStyle/>
+          <a:p>
+            <a:pPr algn="r">
+              <a:spcAft>
+                <a:spcPts val="600"/>
+              </a:spcAft>
+            </a:pPr>
+            <a:r>
+              <a:rPr sz="1000" b="0">
+                <a:solidFill>
+                  <a:srgbClr val="8FB5A1"/>
+                </a:solidFill>
+                <a:latin typeface="Segoe UI"/>
+              </a:rPr>
+              <a:t>9/9</a:t>
             </a:r>
           </a:p>
         </p:txBody>

</xml_diff>

<commit_message>
feat(agent): MCP escrow server, pin-proof, evidence, 9-slide deck; 90 tests
</commit_message>
<xml_diff>
--- a/docs/deck.pptx
+++ b/docs/deck.pptx
@@ -3548,7 +3548,7 @@
                 </a:solidFill>
                 <a:latin typeface="Segoe UI"/>
               </a:rPr>
-              <a:t>Sourcify exact_match · 79 tests · no owner, no fee</a:t>
+              <a:t>Sourcify exact_match · 90 tests · no owner, no fee</a:t>
             </a:r>
           </a:p>
         </p:txBody>
@@ -6491,7 +6491,7 @@
                 </a:solidFill>
                 <a:latin typeface="Segoe UI"/>
               </a:rPr>
-              <a:t>79 tests</a:t>
+              <a:t>90 tests</a:t>
             </a:r>
           </a:p>
         </p:txBody>
@@ -7201,7 +7201,7 @@
                 </a:solidFill>
                 <a:latin typeface="Segoe UI"/>
               </a:rPr>
-              <a:t>npm test        # 79 passing</a:t>
+              <a:t>npm test        # 90 passing</a:t>
             </a:r>
           </a:p>
           <a:p>
@@ -9333,13 +9333,45 @@
               </a:spcAft>
             </a:pPr>
             <a:r>
+              <a:rPr sz="1100" b="0">
+                <a:solidFill>
+                  <a:srgbClr val="E8F5EE"/>
+                </a:solidFill>
+                <a:latin typeface="Segoe UI"/>
+              </a:rPr>
+              <a:t>•  CLI: status / jobs list / job get / watch / verify</a:t>
+            </a:r>
+          </a:p>
+          <a:p>
+            <a:pPr algn="l" indent="-171450" marL="171450">
+              <a:spcAft>
+                <a:spcPts val="600"/>
+              </a:spcAft>
+            </a:pPr>
+            <a:r>
+              <a:rPr sz="1100" b="0">
+                <a:solidFill>
+                  <a:srgbClr val="E8F5EE"/>
+                </a:solidFill>
+                <a:latin typeface="Segoe UI"/>
+              </a:rPr>
+              <a:t>•  MCP: create_gig / fund_gig / submit / approve / dispute / status</a:t>
+            </a:r>
+          </a:p>
+          <a:p>
+            <a:pPr algn="l" indent="-171450" marL="171450">
+              <a:spcAft>
+                <a:spcPts val="600"/>
+              </a:spcAft>
+            </a:pPr>
+            <a:r>
               <a:rPr sz="1200" b="0">
                 <a:solidFill>
                   <a:srgbClr val="E8F5EE"/>
                 </a:solidFill>
                 <a:latin typeface="Segoe UI"/>
               </a:rPr>
-              <a:t>•  status · jobs list · job get · watch · verify</a:t>
+              <a:t>•  lifecycle commands build calldata; --dry-run is the default</a:t>
             </a:r>
           </a:p>
           <a:p>
@@ -9355,7 +9387,7 @@
                 </a:solidFill>
                 <a:latin typeface="Segoe UI"/>
               </a:rPr>
-              <a:t>•  lifecycle commands build calldata; --dry-run is the default</a:t>
+              <a:t>•  exit codes 0/1/2/3 = ok / input / network / revert</a:t>
             </a:r>
           </a:p>
           <a:p>
@@ -9371,23 +9403,7 @@
                 </a:solidFill>
                 <a:latin typeface="Segoe UI"/>
               </a:rPr>
-              <a:t>•  exit codes 0/1/2/3 = ok / input / network / revert</a:t>
-            </a:r>
-          </a:p>
-          <a:p>
-            <a:pPr algn="l" indent="-171450" marL="171450">
-              <a:spcAft>
-                <a:spcPts val="600"/>
-              </a:spcAft>
-            </a:pPr>
-            <a:r>
-              <a:rPr sz="1200" b="0">
-                <a:solidFill>
-                  <a:srgbClr val="E8F5EE"/>
-                </a:solidFill>
-                <a:latin typeface="Segoe UI"/>
-              </a:rPr>
-              <a:t>•  10 new tests; npm test = 79 passing</a:t>
+              <a:t>•  21 new tests (CLI + MCP + pin); npm test = 90 passing</a:t>
             </a:r>
           </a:p>
           <a:p>
@@ -9682,7 +9698,7 @@
                 </a:solidFill>
                 <a:latin typeface="Segoe UI"/>
               </a:rPr>
-              <a:t>79 passing</a:t>
+              <a:t>90 passing</a:t>
             </a:r>
           </a:p>
         </p:txBody>

</xml_diff>

<commit_message>
docs: slide 9 adds Sourcify exact_match fact
</commit_message>
<xml_diff>
--- a/docs/deck.pptx
+++ b/docs/deck.pptx
@@ -9420,6 +9420,22 @@
                 <a:latin typeface="Segoe UI"/>
               </a:rPr>
               <a:t>•  commit fbf6fb8; contract unchanged</a:t>
+            </a:r>
+          </a:p>
+          <a:p>
+            <a:pPr algn="l" indent="-171450" marL="171450">
+              <a:spcAft>
+                <a:spcPts val="600"/>
+              </a:spcAft>
+            </a:pPr>
+            <a:r>
+              <a:rPr sz="1100" b="0">
+                <a:solidFill>
+                  <a:srgbClr val="E8F5EE"/>
+                </a:solidFill>
+                <a:latin typeface="Segoe UI"/>
+              </a:rPr>
+              <a:t>•  Sourcify exact_match · creation + runtime</a:t>
             </a:r>
           </a:p>
           <a:p>

</xml_diff>

<commit_message>
formal: Lean CI workflow, badge, security invariants, slide 10
</commit_message>
<xml_diff>
--- a/docs/deck.pptx
+++ b/docs/deck.pptx
@@ -14,6 +14,7 @@
     <p:sldId id="262" r:id="rId13"/>
     <p:sldId id="263" r:id="rId14"/>
     <p:sldId id="264" r:id="rId15"/>
+    <p:sldId id="265" r:id="rId16"/>
   </p:sldIdLst>
   <p:sldSz cx="12191695" cy="6858000" type="screen4x3"/>
   <p:notesSz cx="6858000" cy="9144000"/>
@@ -3626,7 +3627,702 @@
                 </a:solidFill>
                 <a:latin typeface="Segoe UI"/>
               </a:rPr>
-              <a:t>1/9</a:t>
+              <a:t>1/10</a:t>
+            </a:r>
+          </a:p>
+        </p:txBody>
+      </p:sp>
+    </p:spTree>
+  </p:cSld>
+  <p:clrMapOvr>
+    <a:masterClrMapping/>
+  </p:clrMapOvr>
+</p:sld>
+</file>
+
+<file path=ppt/slides/slide10.xml><?xml version="1.0" encoding="utf-8"?>
+<p:sld xmlns:a="http://schemas.openxmlformats.org/drawingml/2006/main" xmlns:p="http://schemas.openxmlformats.org/presentationml/2006/main" xmlns:r="http://schemas.openxmlformats.org/officeDocument/2006/relationships">
+  <p:cSld>
+    <p:bg>
+      <p:bgPr>
+        <a:solidFill>
+          <a:srgbClr val="04130C"/>
+        </a:solidFill>
+        <a:effectLst/>
+      </p:bgPr>
+    </p:bg>
+    <p:spTree>
+      <p:nvGrpSpPr>
+        <p:cNvPr id="1" name=""/>
+        <p:cNvGrpSpPr/>
+        <p:nvPr/>
+      </p:nvGrpSpPr>
+      <p:grpSpPr/>
+      <p:sp>
+        <p:nvSpPr>
+          <p:cNvPr id="2" name="TextBox 1"/>
+          <p:cNvSpPr txBox="1"/>
+          <p:nvPr/>
+        </p:nvSpPr>
+        <p:spPr>
+          <a:xfrm>
+            <a:off x="640080" y="411480"/>
+            <a:ext cx="10972800" cy="365760"/>
+          </a:xfrm>
+          <a:prstGeom prst="rect">
+            <a:avLst/>
+          </a:prstGeom>
+          <a:noFill/>
+        </p:spPr>
+        <p:txBody>
+          <a:bodyPr wrap="square" anchor="t" lIns="0" rIns="0" tIns="0" bIns="0">
+            <a:spAutoFit/>
+          </a:bodyPr>
+          <a:lstStyle/>
+          <a:p>
+            <a:pPr algn="l">
+              <a:spcAft>
+                <a:spcPts val="600"/>
+              </a:spcAft>
+            </a:pPr>
+            <a:r>
+              <a:rPr sz="1200" b="1">
+                <a:solidFill>
+                  <a:srgbClr val="00D68F"/>
+                </a:solidFill>
+                <a:latin typeface="Segoe UI"/>
+              </a:rPr>
+              <a:t>FORMAL ACCOUNTING · LEAN 4</a:t>
+            </a:r>
+          </a:p>
+        </p:txBody>
+      </p:sp>
+      <p:sp>
+        <p:nvSpPr>
+          <p:cNvPr id="3" name="TextBox 2"/>
+          <p:cNvSpPr txBox="1"/>
+          <p:nvPr/>
+        </p:nvSpPr>
+        <p:spPr>
+          <a:xfrm>
+            <a:off x="640080" y="777240"/>
+            <a:ext cx="10972800" cy="914400"/>
+          </a:xfrm>
+          <a:prstGeom prst="rect">
+            <a:avLst/>
+          </a:prstGeom>
+          <a:noFill/>
+        </p:spPr>
+        <p:txBody>
+          <a:bodyPr wrap="square" anchor="t" lIns="0" rIns="0" tIns="0" bIns="0">
+            <a:spAutoFit/>
+          </a:bodyPr>
+          <a:lstStyle/>
+          <a:p>
+            <a:pPr algn="l">
+              <a:spcAft>
+                <a:spcPts val="600"/>
+              </a:spcAft>
+            </a:pPr>
+            <a:r>
+              <a:rPr sz="3400" b="1">
+                <a:solidFill>
+                  <a:srgbClr val="E8F5EE"/>
+                </a:solidFill>
+                <a:latin typeface="Segoe UI"/>
+              </a:rPr>
+              <a:t>Machine-checked invariants, honest scope</a:t>
+            </a:r>
+          </a:p>
+        </p:txBody>
+      </p:sp>
+      <p:sp>
+        <p:nvSpPr>
+          <p:cNvPr id="4" name="Rectangle 3"/>
+          <p:cNvSpPr/>
+          <p:nvPr/>
+        </p:nvSpPr>
+        <p:spPr>
+          <a:xfrm>
+            <a:off x="640080" y="1691640"/>
+            <a:ext cx="1463040" cy="38100"/>
+          </a:xfrm>
+          <a:prstGeom prst="rect">
+            <a:avLst/>
+          </a:prstGeom>
+          <a:solidFill>
+            <a:srgbClr val="00D68F"/>
+          </a:solidFill>
+          <a:ln>
+            <a:noFill/>
+          </a:ln>
+        </p:spPr>
+        <p:style>
+          <a:lnRef idx="1">
+            <a:schemeClr val="accent1"/>
+          </a:lnRef>
+          <a:fillRef idx="3">
+            <a:schemeClr val="accent1"/>
+          </a:fillRef>
+          <a:effectRef idx="2">
+            <a:schemeClr val="accent1"/>
+          </a:effectRef>
+          <a:fontRef idx="minor">
+            <a:schemeClr val="lt1"/>
+          </a:fontRef>
+        </p:style>
+        <p:txBody>
+          <a:bodyPr rtlCol="0" anchor="ctr"/>
+          <a:lstStyle/>
+          <a:p>
+            <a:pPr algn="ctr"/>
+          </a:p>
+        </p:txBody>
+      </p:sp>
+      <p:sp>
+        <p:nvSpPr>
+          <p:cNvPr id="5" name="Rounded Rectangle 4"/>
+          <p:cNvSpPr/>
+          <p:nvPr/>
+        </p:nvSpPr>
+        <p:spPr>
+          <a:xfrm>
+            <a:off x="640080" y="1920240"/>
+            <a:ext cx="6675120" cy="4160520"/>
+          </a:xfrm>
+          <a:prstGeom prst="roundRect">
+            <a:avLst>
+              <a:gd name="adj" fmla="val 6000"/>
+            </a:avLst>
+          </a:prstGeom>
+          <a:solidFill>
+            <a:srgbClr val="0A2015"/>
+          </a:solidFill>
+          <a:ln w="12700">
+            <a:solidFill>
+              <a:srgbClr val="1D4A33"/>
+            </a:solidFill>
+          </a:ln>
+          <a:effectLst/>
+        </p:spPr>
+        <p:style>
+          <a:lnRef idx="1">
+            <a:schemeClr val="accent1"/>
+          </a:lnRef>
+          <a:fillRef idx="3">
+            <a:schemeClr val="accent1"/>
+          </a:fillRef>
+          <a:effectRef idx="2">
+            <a:schemeClr val="accent1"/>
+          </a:effectRef>
+          <a:fontRef idx="minor">
+            <a:schemeClr val="lt1"/>
+          </a:fontRef>
+        </p:style>
+        <p:txBody>
+          <a:bodyPr rtlCol="0" anchor="ctr"/>
+          <a:lstStyle/>
+          <a:p>
+            <a:pPr algn="ctr"/>
+          </a:p>
+        </p:txBody>
+      </p:sp>
+      <p:sp>
+        <p:nvSpPr>
+          <p:cNvPr id="6" name="TextBox 5"/>
+          <p:cNvSpPr txBox="1"/>
+          <p:nvPr/>
+        </p:nvSpPr>
+        <p:spPr>
+          <a:xfrm>
+            <a:off x="868680" y="2084831"/>
+            <a:ext cx="6217920" cy="3840480"/>
+          </a:xfrm>
+          <a:prstGeom prst="rect">
+            <a:avLst/>
+          </a:prstGeom>
+          <a:noFill/>
+        </p:spPr>
+        <p:txBody>
+          <a:bodyPr wrap="square" anchor="t" lIns="0" rIns="0" tIns="0" bIns="0">
+            <a:spAutoFit/>
+          </a:bodyPr>
+          <a:lstStyle/>
+          <a:p>
+            <a:pPr algn="l">
+              <a:spcAft>
+                <a:spcPts val="200"/>
+              </a:spcAft>
+            </a:pPr>
+            <a:r>
+              <a:rPr sz="1400" b="1">
+                <a:solidFill>
+                  <a:srgbClr val="00D68F"/>
+                </a:solidFill>
+                <a:latin typeface="Segoe UI"/>
+              </a:rPr>
+              <a:t>Pinned Lean 4.30.0 · 0 sorry</a:t>
+            </a:r>
+          </a:p>
+          <a:p>
+            <a:pPr algn="l">
+              <a:spcAft>
+                <a:spcPts val="200"/>
+              </a:spcAft>
+            </a:pPr>
+            <a:r>
+              <a:rPr sz="1000" b="0">
+                <a:solidFill>
+                  <a:srgbClr val="8FB5A1"/>
+                </a:solidFill>
+                <a:latin typeface="Segoe UI"/>
+              </a:rPr>
+              <a:t>An arithmetic model of the ledger, not a verification of Solidity bytecode.</a:t>
+            </a:r>
+          </a:p>
+          <a:p>
+            <a:pPr algn="l">
+              <a:spcAft>
+                <a:spcPts val="200"/>
+              </a:spcAft>
+            </a:pPr>
+            <a:r>
+              <a:rPr sz="400" b="0">
+                <a:solidFill>
+                  <a:srgbClr val="E8F5EE"/>
+                </a:solidFill>
+                <a:latin typeface="Segoe UI"/>
+              </a:rPr>
+              <a:t/>
+            </a:r>
+          </a:p>
+          <a:p>
+            <a:pPr algn="l">
+              <a:spcAft>
+                <a:spcPts val="200"/>
+              </a:spcAft>
+            </a:pPr>
+            <a:r>
+              <a:rPr sz="1300" b="1">
+                <a:solidFill>
+                  <a:srgbClr val="E8F5EE"/>
+                </a:solidFill>
+                <a:latin typeface="Segoe UI"/>
+              </a:rPr>
+              <a:t>No money creation</a:t>
+            </a:r>
+          </a:p>
+          <a:p>
+            <a:pPr algn="l">
+              <a:spcAft>
+                <a:spcPts val="200"/>
+              </a:spcAft>
+            </a:pPr>
+            <a:r>
+              <a:rPr sz="1100" b="0">
+                <a:solidFill>
+                  <a:srgbClr val="E8F5EE"/>
+                </a:solidFill>
+                <a:latin typeface="Segoe UI"/>
+              </a:rPr>
+              <a:t>paidOut + refunded ≤ funded</a:t>
+            </a:r>
+          </a:p>
+          <a:p>
+            <a:pPr algn="l">
+              <a:spcAft>
+                <a:spcPts val="200"/>
+              </a:spcAft>
+            </a:pPr>
+            <a:r>
+              <a:rPr sz="1000" b="0">
+                <a:solidFill>
+                  <a:srgbClr val="8FB5A1"/>
+                </a:solidFill>
+                <a:latin typeface="Segoe UI"/>
+              </a:rPr>
+              <a:t>MezoGig.no_money_creation</a:t>
+            </a:r>
+          </a:p>
+          <a:p>
+            <a:pPr algn="l">
+              <a:spcAft>
+                <a:spcPts val="200"/>
+              </a:spcAft>
+            </a:pPr>
+            <a:r>
+              <a:rPr sz="300" b="0">
+                <a:solidFill>
+                  <a:srgbClr val="E8F5EE"/>
+                </a:solidFill>
+                <a:latin typeface="Segoe UI"/>
+              </a:rPr>
+              <a:t/>
+            </a:r>
+          </a:p>
+          <a:p>
+            <a:pPr algn="l">
+              <a:spcAft>
+                <a:spcPts val="200"/>
+              </a:spcAft>
+            </a:pPr>
+            <a:r>
+              <a:rPr sz="1300" b="1">
+                <a:solidFill>
+                  <a:srgbClr val="E8F5EE"/>
+                </a:solidFill>
+                <a:latin typeface="Segoe UI"/>
+              </a:rPr>
+              <a:t>Budget completeness</a:t>
+            </a:r>
+          </a:p>
+          <a:p>
+            <a:pPr algn="l">
+              <a:spcAft>
+                <a:spcPts val="200"/>
+              </a:spcAft>
+            </a:pPr>
+            <a:r>
+              <a:rPr sz="1100" b="0">
+                <a:solidFill>
+                  <a:srgbClr val="E8F5EE"/>
+                </a:solidFill>
+                <a:latin typeface="Segoe UI"/>
+              </a:rPr>
+              <a:t>milestones.sum = funded</a:t>
+            </a:r>
+          </a:p>
+          <a:p>
+            <a:pPr algn="l">
+              <a:spcAft>
+                <a:spcPts val="200"/>
+              </a:spcAft>
+            </a:pPr>
+            <a:r>
+              <a:rPr sz="1000" b="0">
+                <a:solidFill>
+                  <a:srgbClr val="8FB5A1"/>
+                </a:solidFill>
+                <a:latin typeface="Segoe UI"/>
+              </a:rPr>
+              <a:t>MezoGig.budget_complete</a:t>
+            </a:r>
+          </a:p>
+          <a:p>
+            <a:pPr algn="l">
+              <a:spcAft>
+                <a:spcPts val="200"/>
+              </a:spcAft>
+            </a:pPr>
+            <a:r>
+              <a:rPr sz="300" b="0">
+                <a:solidFill>
+                  <a:srgbClr val="E8F5EE"/>
+                </a:solidFill>
+                <a:latin typeface="Segoe UI"/>
+              </a:rPr>
+              <a:t/>
+            </a:r>
+          </a:p>
+          <a:p>
+            <a:pPr algn="l">
+              <a:spcAft>
+                <a:spcPts val="200"/>
+              </a:spcAft>
+            </a:pPr>
+            <a:r>
+              <a:rPr sz="1300" b="1">
+                <a:solidFill>
+                  <a:srgbClr val="E8F5EE"/>
+                </a:solidFill>
+                <a:latin typeface="Segoe UI"/>
+              </a:rPr>
+              <a:t>Dispute exactness</a:t>
+            </a:r>
+          </a:p>
+          <a:p>
+            <a:pPr algn="l">
+              <a:spcAft>
+                <a:spcPts val="200"/>
+              </a:spcAft>
+            </a:pPr>
+            <a:r>
+              <a:rPr sz="1100" b="0">
+                <a:solidFill>
+                  <a:srgbClr val="E8F5EE"/>
+                </a:solidFill>
+                <a:latin typeface="Segoe UI"/>
+              </a:rPr>
+              <a:t>a + b = amount</a:t>
+            </a:r>
+          </a:p>
+          <a:p>
+            <a:pPr algn="l">
+              <a:spcAft>
+                <a:spcPts val="200"/>
+              </a:spcAft>
+            </a:pPr>
+            <a:r>
+              <a:rPr sz="1000" b="0">
+                <a:solidFill>
+                  <a:srgbClr val="8FB5A1"/>
+                </a:solidFill>
+                <a:latin typeface="Segoe UI"/>
+              </a:rPr>
+              <a:t>MezoGig.dispute_split_correct</a:t>
+            </a:r>
+          </a:p>
+          <a:p>
+            <a:pPr algn="l">
+              <a:spcAft>
+                <a:spcPts val="200"/>
+              </a:spcAft>
+            </a:pPr>
+            <a:r>
+              <a:rPr sz="300" b="0">
+                <a:solidFill>
+                  <a:srgbClr val="E8F5EE"/>
+                </a:solidFill>
+                <a:latin typeface="Segoe UI"/>
+              </a:rPr>
+              <a:t/>
+            </a:r>
+          </a:p>
+          <a:p>
+            <a:pPr algn="l">
+              <a:spcAft>
+                <a:spcPts val="200"/>
+              </a:spcAft>
+            </a:pPr>
+            <a:r>
+              <a:rPr sz="1300" b="1">
+                <a:solidFill>
+                  <a:srgbClr val="E8F5EE"/>
+                </a:solidFill>
+                <a:latin typeface="Segoe UI"/>
+              </a:rPr>
+              <a:t>Floor rounding never creates money</a:t>
+            </a:r>
+          </a:p>
+          <a:p>
+            <a:pPr algn="l">
+              <a:spcAft>
+                <a:spcPts val="200"/>
+              </a:spcAft>
+            </a:pPr>
+            <a:r>
+              <a:rPr sz="1100" b="0">
+                <a:solidFill>
+                  <a:srgbClr val="E8F5EE"/>
+                </a:solidFill>
+                <a:latin typeface="Segoe UI"/>
+              </a:rPr>
+              <a:t>Σ (total / n) ≤ total</a:t>
+            </a:r>
+          </a:p>
+          <a:p>
+            <a:pPr algn="l">
+              <a:spcAft>
+                <a:spcPts val="200"/>
+              </a:spcAft>
+            </a:pPr>
+            <a:r>
+              <a:rPr sz="1000" b="0">
+                <a:solidFill>
+                  <a:srgbClr val="8FB5A1"/>
+                </a:solidFill>
+                <a:latin typeface="Segoe UI"/>
+              </a:rPr>
+              <a:t>MezoGig.floor_split_no_gain</a:t>
+            </a:r>
+          </a:p>
+        </p:txBody>
+      </p:sp>
+      <p:pic>
+        <p:nvPicPr>
+          <p:cNvPr id="7" name="Picture 6" descr="lean_compile.png"/>
+          <p:cNvPicPr>
+            <a:picLocks noChangeAspect="1"/>
+          </p:cNvPicPr>
+          <p:nvPr/>
+        </p:nvPicPr>
+        <p:blipFill>
+          <a:blip r:embed="rId2"/>
+          <a:stretch>
+            <a:fillRect/>
+          </a:stretch>
+        </p:blipFill>
+        <p:spPr>
+          <a:xfrm>
+            <a:off x="7498079" y="1920240"/>
+            <a:ext cx="4023360" cy="2263140"/>
+          </a:xfrm>
+          <a:prstGeom prst="rect">
+            <a:avLst/>
+          </a:prstGeom>
+        </p:spPr>
+      </p:pic>
+      <p:sp>
+        <p:nvSpPr>
+          <p:cNvPr id="8" name="TextBox 7"/>
+          <p:cNvSpPr txBox="1"/>
+          <p:nvPr/>
+        </p:nvSpPr>
+        <p:spPr>
+          <a:xfrm>
+            <a:off x="7498079" y="4480560"/>
+            <a:ext cx="4023360" cy="1280160"/>
+          </a:xfrm>
+          <a:prstGeom prst="rect">
+            <a:avLst/>
+          </a:prstGeom>
+          <a:noFill/>
+        </p:spPr>
+        <p:txBody>
+          <a:bodyPr wrap="square" anchor="t" lIns="0" rIns="0" tIns="0" bIns="0">
+            <a:spAutoFit/>
+          </a:bodyPr>
+          <a:lstStyle/>
+          <a:p>
+            <a:pPr algn="l">
+              <a:spcAft>
+                <a:spcPts val="600"/>
+              </a:spcAft>
+            </a:pPr>
+            <a:r>
+              <a:rPr sz="1000" b="1">
+                <a:solidFill>
+                  <a:srgbClr val="E8F5EE"/>
+                </a:solidFill>
+                <a:latin typeface="Segoe UI"/>
+              </a:rPr>
+              <a:t>lake env lean Escrow.lean → exit 0</a:t>
+            </a:r>
+          </a:p>
+          <a:p>
+            <a:pPr algn="l">
+              <a:spcAft>
+                <a:spcPts val="600"/>
+              </a:spcAft>
+            </a:pPr>
+            <a:r>
+              <a:rPr sz="900" b="0">
+                <a:solidFill>
+                  <a:srgbClr val="8FB5A1"/>
+                </a:solidFill>
+                <a:latin typeface="Segoe UI"/>
+              </a:rPr>
+              <a:t>CI: .github/workflows/lean.yml · 0 sorry</a:t>
+            </a:r>
+          </a:p>
+          <a:p>
+            <a:pPr algn="l">
+              <a:spcAft>
+                <a:spcPts val="600"/>
+              </a:spcAft>
+            </a:pPr>
+            <a:r>
+              <a:rPr sz="400" b="0">
+                <a:solidFill>
+                  <a:srgbClr val="E8F5EE"/>
+                </a:solidFill>
+                <a:latin typeface="Segoe UI"/>
+              </a:rPr>
+              <a:t/>
+            </a:r>
+          </a:p>
+          <a:p>
+            <a:pPr algn="l">
+              <a:spcAft>
+                <a:spcPts val="600"/>
+              </a:spcAft>
+            </a:pPr>
+            <a:r>
+              <a:rPr sz="900" b="0">
+                <a:solidFill>
+                  <a:srgbClr val="FFB020"/>
+                </a:solidFill>
+                <a:latin typeface="Segoe UI"/>
+              </a:rPr>
+              <a:t>Scope: arithmetic model only; uint128 overflow, tokens and weighted splits are out of scope.</a:t>
+            </a:r>
+          </a:p>
+        </p:txBody>
+      </p:sp>
+      <p:sp>
+        <p:nvSpPr>
+          <p:cNvPr id="9" name="TextBox 8"/>
+          <p:cNvSpPr txBox="1"/>
+          <p:nvPr/>
+        </p:nvSpPr>
+        <p:spPr>
+          <a:xfrm>
+            <a:off x="640080" y="6400800"/>
+            <a:ext cx="8229600" cy="274320"/>
+          </a:xfrm>
+          <a:prstGeom prst="rect">
+            <a:avLst/>
+          </a:prstGeom>
+          <a:noFill/>
+        </p:spPr>
+        <p:txBody>
+          <a:bodyPr wrap="square" anchor="t" lIns="0" rIns="0" tIns="0" bIns="0">
+            <a:spAutoFit/>
+          </a:bodyPr>
+          <a:lstStyle/>
+          <a:p>
+            <a:pPr algn="l">
+              <a:spcAft>
+                <a:spcPts val="600"/>
+              </a:spcAft>
+            </a:pPr>
+            <a:r>
+              <a:rPr sz="1000" b="0">
+                <a:solidFill>
+                  <a:srgbClr val="8FB5A1"/>
+                </a:solidFill>
+                <a:latin typeface="Segoe UI"/>
+              </a:rPr>
+              <a:t>MezoGig · milestone escrow in MUSD on Mezo · AKINDO “Build with MUSD and MEZO”, Wave 1</a:t>
+            </a:r>
+          </a:p>
+        </p:txBody>
+      </p:sp>
+      <p:sp>
+        <p:nvSpPr>
+          <p:cNvPr id="10" name="TextBox 9"/>
+          <p:cNvSpPr txBox="1"/>
+          <p:nvPr/>
+        </p:nvSpPr>
+        <p:spPr>
+          <a:xfrm>
+            <a:off x="10789920" y="6400800"/>
+            <a:ext cx="822960" cy="274320"/>
+          </a:xfrm>
+          <a:prstGeom prst="rect">
+            <a:avLst/>
+          </a:prstGeom>
+          <a:noFill/>
+        </p:spPr>
+        <p:txBody>
+          <a:bodyPr wrap="square" anchor="t" lIns="0" rIns="0" tIns="0" bIns="0">
+            <a:spAutoFit/>
+          </a:bodyPr>
+          <a:lstStyle/>
+          <a:p>
+            <a:pPr algn="r">
+              <a:spcAft>
+                <a:spcPts val="600"/>
+              </a:spcAft>
+            </a:pPr>
+            <a:r>
+              <a:rPr sz="1000" b="0">
+                <a:solidFill>
+                  <a:srgbClr val="8FB5A1"/>
+                </a:solidFill>
+                <a:latin typeface="Segoe UI"/>
+              </a:rPr>
+              <a:t>10/10</a:t>
             </a:r>
           </a:p>
         </p:txBody>
@@ -4201,7 +4897,7 @@
                 </a:solidFill>
                 <a:latin typeface="Segoe UI"/>
               </a:rPr>
-              <a:t>2/9</a:t>
+              <a:t>2/10</a:t>
             </a:r>
           </a:p>
         </p:txBody>
@@ -5165,7 +5861,7 @@
                 </a:solidFill>
                 <a:latin typeface="Segoe UI"/>
               </a:rPr>
-              <a:t>3/9</a:t>
+              <a:t>3/10</a:t>
             </a:r>
           </a:p>
         </p:txBody>
@@ -5740,7 +6436,7 @@
                 </a:solidFill>
                 <a:latin typeface="Segoe UI"/>
               </a:rPr>
-              <a:t>4/9</a:t>
+              <a:t>4/10</a:t>
             </a:r>
           </a:p>
         </p:txBody>
@@ -6257,7 +6953,7 @@
                 </a:solidFill>
                 <a:latin typeface="Segoe UI"/>
               </a:rPr>
-              <a:t>5/9</a:t>
+              <a:t>5/10</a:t>
             </a:r>
           </a:p>
         </p:txBody>
@@ -7446,7 +8142,7 @@
                 </a:solidFill>
                 <a:latin typeface="Segoe UI"/>
               </a:rPr>
-              <a:t>6/9</a:t>
+              <a:t>6/10</a:t>
             </a:r>
           </a:p>
         </p:txBody>
@@ -8184,7 +8880,7 @@
                 </a:solidFill>
                 <a:latin typeface="Segoe UI"/>
               </a:rPr>
-              <a:t>7/9</a:t>
+              <a:t>7/10</a:t>
             </a:r>
           </a:p>
         </p:txBody>
@@ -9057,7 +9753,7 @@
                 </a:solidFill>
                 <a:latin typeface="Segoe UI"/>
               </a:rPr>
-              <a:t>8/9</a:t>
+              <a:t>8/10</a:t>
             </a:r>
           </a:p>
         </p:txBody>
@@ -9792,7 +10488,7 @@
                 </a:solidFill>
                 <a:latin typeface="Segoe UI"/>
               </a:rPr>
-              <a:t>9/9</a:t>
+              <a:t>9/10</a:t>
             </a:r>
           </a:p>
         </p:txBody>

</xml_diff>

<commit_message>
formal: expanded Lean model (asset assumptions + permit replay), slide 10 groups
</commit_message>
<xml_diff>
--- a/docs/deck.pptx
+++ b/docs/deck.pptx
@@ -3855,13 +3855,13 @@
               </a:spcAft>
             </a:pPr>
             <a:r>
-              <a:rPr sz="1400" b="1">
+              <a:rPr sz="1200" b="1">
                 <a:solidFill>
                   <a:srgbClr val="00D68F"/>
                 </a:solidFill>
                 <a:latin typeface="Segoe UI"/>
               </a:rPr>
-              <a:t>Pinned Lean 4.30.0 · 0 sorry</a:t>
+              <a:t>12 headline theorems · 3 groups · 0 sorry</a:t>
             </a:r>
           </a:p>
           <a:p>
@@ -3905,11 +3905,27 @@
             <a:r>
               <a:rPr sz="1300" b="1">
                 <a:solidFill>
+                  <a:srgbClr val="00D68F"/>
+                </a:solidFill>
+                <a:latin typeface="Segoe UI"/>
+              </a:rPr>
+              <a:t>Accounting</a:t>
+            </a:r>
+          </a:p>
+          <a:p>
+            <a:pPr algn="l">
+              <a:spcAft>
+                <a:spcPts val="200"/>
+              </a:spcAft>
+            </a:pPr>
+            <a:r>
+              <a:rPr sz="900" b="0">
+                <a:solidFill>
                   <a:srgbClr val="E8F5EE"/>
                 </a:solidFill>
                 <a:latin typeface="Segoe UI"/>
               </a:rPr>
-              <a:t>No money creation</a:t>
+              <a:t>no_money_creation · budget_complete</a:t>
             </a:r>
           </a:p>
           <a:p>
@@ -3919,13 +3935,13 @@
               </a:spcAft>
             </a:pPr>
             <a:r>
-              <a:rPr sz="1100" b="0">
+              <a:rPr sz="900" b="0">
                 <a:solidFill>
                   <a:srgbClr val="E8F5EE"/>
                 </a:solidFill>
                 <a:latin typeface="Segoe UI"/>
               </a:rPr>
-              <a:t>paidOut + refunded ≤ funded</a:t>
+              <a:t>dispute_split_correct · floor_split_no_gain</a:t>
             </a:r>
           </a:p>
           <a:p>
@@ -3935,13 +3951,13 @@
               </a:spcAft>
             </a:pPr>
             <a:r>
-              <a:rPr sz="1000" b="0">
-                <a:solidFill>
-                  <a:srgbClr val="8FB5A1"/>
-                </a:solidFill>
-                <a:latin typeface="Segoe UI"/>
-              </a:rPr>
-              <a:t>MezoGig.no_money_creation</a:t>
+              <a:rPr sz="200" b="0">
+                <a:solidFill>
+                  <a:srgbClr val="E8F5EE"/>
+                </a:solidFill>
+                <a:latin typeface="Segoe UI"/>
+              </a:rPr>
+              <a:t/>
             </a:r>
           </a:p>
           <a:p>
@@ -3951,6 +3967,134 @@
               </a:spcAft>
             </a:pPr>
             <a:r>
+              <a:rPr sz="1300" b="1">
+                <a:solidFill>
+                  <a:srgbClr val="00D68F"/>
+                </a:solidFill>
+                <a:latin typeface="Segoe UI"/>
+              </a:rPr>
+              <a:t>Asset assumptions</a:t>
+            </a:r>
+          </a:p>
+          <a:p>
+            <a:pPr algn="l">
+              <a:spcAft>
+                <a:spcPts val="200"/>
+              </a:spcAft>
+            </a:pPr>
+            <a:r>
+              <a:rPr sz="900" b="0">
+                <a:solidFill>
+                  <a:srgbClr val="E8F5EE"/>
+                </a:solidFill>
+                <a:latin typeface="Segoe UI"/>
+              </a:rPr>
+              <a:t>non-fee, non-rebasing ERC-20; MUSD is such a token</a:t>
+            </a:r>
+          </a:p>
+          <a:p>
+            <a:pPr algn="l">
+              <a:spcAft>
+                <a:spcPts val="200"/>
+              </a:spcAft>
+            </a:pPr>
+            <a:r>
+              <a:rPr sz="800" b="0">
+                <a:solidFill>
+                  <a:srgbClr val="E8F5EE"/>
+                </a:solidFill>
+                <a:latin typeface="Segoe UI"/>
+              </a:rPr>
+              <a:t>no_fee_preserves_budget · fee_on_transfer_breaks_budget</a:t>
+            </a:r>
+          </a:p>
+          <a:p>
+            <a:pPr algn="l">
+              <a:spcAft>
+                <a:spcPts val="200"/>
+              </a:spcAft>
+            </a:pPr>
+            <a:r>
+              <a:rPr sz="900" b="0">
+                <a:solidFill>
+                  <a:srgbClr val="E8F5EE"/>
+                </a:solidFill>
+                <a:latin typeface="Segoe UI"/>
+              </a:rPr>
+              <a:t>fee_shortfall · rebasing_breaks_locked</a:t>
+            </a:r>
+          </a:p>
+          <a:p>
+            <a:pPr algn="l">
+              <a:spcAft>
+                <a:spcPts val="200"/>
+              </a:spcAft>
+            </a:pPr>
+            <a:r>
+              <a:rPr sz="200" b="0">
+                <a:solidFill>
+                  <a:srgbClr val="E8F5EE"/>
+                </a:solidFill>
+                <a:latin typeface="Segoe UI"/>
+              </a:rPr>
+              <a:t/>
+            </a:r>
+          </a:p>
+          <a:p>
+            <a:pPr algn="l">
+              <a:spcAft>
+                <a:spcPts val="200"/>
+              </a:spcAft>
+            </a:pPr>
+            <a:r>
+              <a:rPr sz="1300" b="1">
+                <a:solidFill>
+                  <a:srgbClr val="00D68F"/>
+                </a:solidFill>
+                <a:latin typeface="Segoe UI"/>
+              </a:rPr>
+              <a:t>Permit replay</a:t>
+            </a:r>
+          </a:p>
+          <a:p>
+            <a:pPr algn="l">
+              <a:spcAft>
+                <a:spcPts val="200"/>
+              </a:spcAft>
+            </a:pPr>
+            <a:r>
+              <a:rPr sz="900" b="0">
+                <a:solidFill>
+                  <a:srgbClr val="E8F5EE"/>
+                </a:solidFill>
+                <a:latin typeface="Segoe UI"/>
+              </a:rPr>
+              <a:t>nonce_strictly_increases · no_replay</a:t>
+            </a:r>
+          </a:p>
+          <a:p>
+            <a:pPr algn="l">
+              <a:spcAft>
+                <a:spcPts val="200"/>
+              </a:spcAft>
+            </a:pPr>
+            <a:r>
+              <a:rPr sz="900" b="0">
+                <a:solidFill>
+                  <a:srgbClr val="E8F5EE"/>
+                </a:solidFill>
+                <a:latin typeface="Segoe UI"/>
+              </a:rPr>
+              <a:t>no_replay_reachable · no_increment_allows_replay</a:t>
+            </a:r>
+          </a:p>
+          <a:p>
+            <a:pPr algn="l">
+              <a:spcAft>
+                <a:spcPts val="200"/>
+              </a:spcAft>
+            </a:pPr>
+            <a:r>
               <a:rPr sz="300" b="0">
                 <a:solidFill>
                   <a:srgbClr val="E8F5EE"/>
@@ -3967,173 +4111,13 @@
               </a:spcAft>
             </a:pPr>
             <a:r>
-              <a:rPr sz="1300" b="1">
-                <a:solidFill>
-                  <a:srgbClr val="E8F5EE"/>
-                </a:solidFill>
-                <a:latin typeface="Segoe UI"/>
-              </a:rPr>
-              <a:t>Budget completeness</a:t>
-            </a:r>
-          </a:p>
-          <a:p>
-            <a:pPr algn="l">
-              <a:spcAft>
-                <a:spcPts val="200"/>
-              </a:spcAft>
-            </a:pPr>
-            <a:r>
-              <a:rPr sz="1100" b="0">
-                <a:solidFill>
-                  <a:srgbClr val="E8F5EE"/>
-                </a:solidFill>
-                <a:latin typeface="Segoe UI"/>
-              </a:rPr>
-              <a:t>milestones.sum = funded</a:t>
-            </a:r>
-          </a:p>
-          <a:p>
-            <a:pPr algn="l">
-              <a:spcAft>
-                <a:spcPts val="200"/>
-              </a:spcAft>
-            </a:pPr>
-            <a:r>
-              <a:rPr sz="1000" b="0">
-                <a:solidFill>
-                  <a:srgbClr val="8FB5A1"/>
-                </a:solidFill>
-                <a:latin typeface="Segoe UI"/>
-              </a:rPr>
-              <a:t>MezoGig.budget_complete</a:t>
-            </a:r>
-          </a:p>
-          <a:p>
-            <a:pPr algn="l">
-              <a:spcAft>
-                <a:spcPts val="200"/>
-              </a:spcAft>
-            </a:pPr>
-            <a:r>
-              <a:rPr sz="300" b="0">
-                <a:solidFill>
-                  <a:srgbClr val="E8F5EE"/>
-                </a:solidFill>
-                <a:latin typeface="Segoe UI"/>
-              </a:rPr>
-              <a:t/>
-            </a:r>
-          </a:p>
-          <a:p>
-            <a:pPr algn="l">
-              <a:spcAft>
-                <a:spcPts val="200"/>
-              </a:spcAft>
-            </a:pPr>
-            <a:r>
-              <a:rPr sz="1300" b="1">
-                <a:solidFill>
-                  <a:srgbClr val="E8F5EE"/>
-                </a:solidFill>
-                <a:latin typeface="Segoe UI"/>
-              </a:rPr>
-              <a:t>Dispute exactness</a:t>
-            </a:r>
-          </a:p>
-          <a:p>
-            <a:pPr algn="l">
-              <a:spcAft>
-                <a:spcPts val="200"/>
-              </a:spcAft>
-            </a:pPr>
-            <a:r>
-              <a:rPr sz="1100" b="0">
-                <a:solidFill>
-                  <a:srgbClr val="E8F5EE"/>
-                </a:solidFill>
-                <a:latin typeface="Segoe UI"/>
-              </a:rPr>
-              <a:t>a + b = amount</a:t>
-            </a:r>
-          </a:p>
-          <a:p>
-            <a:pPr algn="l">
-              <a:spcAft>
-                <a:spcPts val="200"/>
-              </a:spcAft>
-            </a:pPr>
-            <a:r>
-              <a:rPr sz="1000" b="0">
-                <a:solidFill>
-                  <a:srgbClr val="8FB5A1"/>
-                </a:solidFill>
-                <a:latin typeface="Segoe UI"/>
-              </a:rPr>
-              <a:t>MezoGig.dispute_split_correct</a:t>
-            </a:r>
-          </a:p>
-          <a:p>
-            <a:pPr algn="l">
-              <a:spcAft>
-                <a:spcPts val="200"/>
-              </a:spcAft>
-            </a:pPr>
-            <a:r>
-              <a:rPr sz="300" b="0">
-                <a:solidFill>
-                  <a:srgbClr val="E8F5EE"/>
-                </a:solidFill>
-                <a:latin typeface="Segoe UI"/>
-              </a:rPr>
-              <a:t/>
-            </a:r>
-          </a:p>
-          <a:p>
-            <a:pPr algn="l">
-              <a:spcAft>
-                <a:spcPts val="200"/>
-              </a:spcAft>
-            </a:pPr>
-            <a:r>
-              <a:rPr sz="1300" b="1">
-                <a:solidFill>
-                  <a:srgbClr val="E8F5EE"/>
-                </a:solidFill>
-                <a:latin typeface="Segoe UI"/>
-              </a:rPr>
-              <a:t>Floor rounding never creates money</a:t>
-            </a:r>
-          </a:p>
-          <a:p>
-            <a:pPr algn="l">
-              <a:spcAft>
-                <a:spcPts val="200"/>
-              </a:spcAft>
-            </a:pPr>
-            <a:r>
-              <a:rPr sz="1100" b="0">
-                <a:solidFill>
-                  <a:srgbClr val="E8F5EE"/>
-                </a:solidFill>
-                <a:latin typeface="Segoe UI"/>
-              </a:rPr>
-              <a:t>Σ (total / n) ≤ total</a:t>
-            </a:r>
-          </a:p>
-          <a:p>
-            <a:pPr algn="l">
-              <a:spcAft>
-                <a:spcPts val="200"/>
-              </a:spcAft>
-            </a:pPr>
-            <a:r>
-              <a:rPr sz="1000" b="0">
-                <a:solidFill>
-                  <a:srgbClr val="8FB5A1"/>
-                </a:solidFill>
-                <a:latin typeface="Segoe UI"/>
-              </a:rPr>
-              <a:t>MezoGig.floor_split_no_gain</a:t>
+              <a:rPr sz="800" b="0">
+                <a:solidFill>
+                  <a:srgbClr val="FFB020"/>
+                </a:solidFill>
+                <a:latin typeface="Segoe UI"/>
+              </a:rPr>
+              <a:t>Model checked, not bytecode verification. Fee/rebasing are assumptions; if violated, the invariant fails.</a:t>
             </a:r>
           </a:p>
         </p:txBody>

</xml_diff>